<commit_message>
release: publish Standard Report PPT V5.9.6
</commit_message>
<xml_diff>
--- a/assets/company_template.pptx
+++ b/assets/company_template.pptx
@@ -216,7 +216,7 @@
           <a:p>
             <a:fld id="{96AC901F-F269-4E9E-8633-DCC769E8AA74}" type="datetimeFigureOut">
               <a:rPr lang="zh-TW" altLang="en-US" smtClean="0"/>
-              <a:t>2026/7/13</a:t>
+              <a:t>2026/7/16</a:t>
             </a:fld>
             <a:endParaRPr lang="zh-TW" altLang="en-US"/>
           </a:p>
@@ -409,7 +409,7 @@
           <a:p>
             <a:fld id="{893DF0DA-6838-4934-8C97-C6FEC3606769}" type="datetimeFigureOut">
               <a:rPr lang="zh-TW" altLang="en-US" smtClean="0"/>
-              <a:t>2026/7/13</a:t>
+              <a:t>2026/7/16</a:t>
             </a:fld>
             <a:endParaRPr lang="zh-TW" altLang="en-US"/>
           </a:p>
@@ -806,7 +806,7 @@
           <a:p>
             <a:fld id="{D997B5FA-0921-464F-AAE1-844C04324D75}" type="datetimeFigureOut">
               <a:rPr lang="zh-CN" altLang="en-US" smtClean="0"/>
-              <a:t>2026/7/13</a:t>
+              <a:t>2026/7/16</a:t>
             </a:fld>
             <a:endParaRPr lang="zh-CN" altLang="en-US"/>
           </a:p>
@@ -969,7 +969,7 @@
           <a:p>
             <a:fld id="{D997B5FA-0921-464F-AAE1-844C04324D75}" type="datetimeFigureOut">
               <a:rPr lang="zh-CN" altLang="en-US" smtClean="0"/>
-              <a:t>2026/7/13</a:t>
+              <a:t>2026/7/16</a:t>
             </a:fld>
             <a:endParaRPr lang="zh-CN" altLang="en-US"/>
           </a:p>
@@ -1142,7 +1142,7 @@
           <a:p>
             <a:fld id="{D997B5FA-0921-464F-AAE1-844C04324D75}" type="datetimeFigureOut">
               <a:rPr lang="zh-CN" altLang="en-US" smtClean="0"/>
-              <a:t>2026/7/13</a:t>
+              <a:t>2026/7/16</a:t>
             </a:fld>
             <a:endParaRPr lang="zh-CN" altLang="en-US"/>
           </a:p>
@@ -1701,7 +1701,7 @@
           <a:p>
             <a:fld id="{D997B5FA-0921-464F-AAE1-844C04324D75}" type="datetimeFigureOut">
               <a:rPr lang="zh-CN" altLang="en-US" smtClean="0"/>
-              <a:t>2026/7/13</a:t>
+              <a:t>2026/7/16</a:t>
             </a:fld>
             <a:endParaRPr lang="zh-CN" altLang="en-US"/>
           </a:p>
@@ -1941,7 +1941,7 @@
           <a:p>
             <a:fld id="{D997B5FA-0921-464F-AAE1-844C04324D75}" type="datetimeFigureOut">
               <a:rPr lang="zh-CN" altLang="en-US" smtClean="0"/>
-              <a:t>2026/7/13</a:t>
+              <a:t>2026/7/16</a:t>
             </a:fld>
             <a:endParaRPr lang="zh-CN" altLang="en-US"/>
           </a:p>
@@ -2165,7 +2165,7 @@
           <a:p>
             <a:fld id="{D997B5FA-0921-464F-AAE1-844C04324D75}" type="datetimeFigureOut">
               <a:rPr lang="zh-CN" altLang="en-US" smtClean="0"/>
-              <a:t>2026/7/13</a:t>
+              <a:t>2026/7/16</a:t>
             </a:fld>
             <a:endParaRPr lang="zh-CN" altLang="en-US"/>
           </a:p>
@@ -2524,7 +2524,7 @@
           <a:p>
             <a:fld id="{D997B5FA-0921-464F-AAE1-844C04324D75}" type="datetimeFigureOut">
               <a:rPr lang="zh-CN" altLang="en-US" smtClean="0"/>
-              <a:t>2026/7/13</a:t>
+              <a:t>2026/7/16</a:t>
             </a:fld>
             <a:endParaRPr lang="zh-CN" altLang="en-US"/>
           </a:p>
@@ -2636,7 +2636,7 @@
           <a:p>
             <a:fld id="{D997B5FA-0921-464F-AAE1-844C04324D75}" type="datetimeFigureOut">
               <a:rPr lang="zh-CN" altLang="en-US" smtClean="0"/>
-              <a:t>2026/7/13</a:t>
+              <a:t>2026/7/16</a:t>
             </a:fld>
             <a:endParaRPr lang="zh-CN" altLang="en-US"/>
           </a:p>
@@ -2726,7 +2726,7 @@
           <a:p>
             <a:fld id="{D997B5FA-0921-464F-AAE1-844C04324D75}" type="datetimeFigureOut">
               <a:rPr lang="zh-CN" altLang="en-US" smtClean="0"/>
-              <a:t>2026/7/13</a:t>
+              <a:t>2026/7/16</a:t>
             </a:fld>
             <a:endParaRPr lang="zh-CN" altLang="en-US"/>
           </a:p>
@@ -2996,7 +2996,7 @@
           <a:p>
             <a:fld id="{D997B5FA-0921-464F-AAE1-844C04324D75}" type="datetimeFigureOut">
               <a:rPr lang="zh-CN" altLang="en-US" smtClean="0"/>
-              <a:t>2026/7/13</a:t>
+              <a:t>2026/7/16</a:t>
             </a:fld>
             <a:endParaRPr lang="zh-CN" altLang="en-US"/>
           </a:p>
@@ -3243,7 +3243,7 @@
           <a:p>
             <a:fld id="{D997B5FA-0921-464F-AAE1-844C04324D75}" type="datetimeFigureOut">
               <a:rPr lang="zh-CN" altLang="en-US" smtClean="0"/>
-              <a:t>2026/7/13</a:t>
+              <a:t>2026/7/16</a:t>
             </a:fld>
             <a:endParaRPr lang="zh-CN" altLang="en-US"/>
           </a:p>
@@ -3449,7 +3449,7 @@
           <a:p>
             <a:fld id="{D997B5FA-0921-464F-AAE1-844C04324D75}" type="datetimeFigureOut">
               <a:rPr lang="zh-CN" altLang="en-US" smtClean="0"/>
-              <a:t>2026/7/13</a:t>
+              <a:t>2026/7/16</a:t>
             </a:fld>
             <a:endParaRPr lang="zh-CN" altLang="en-US"/>
           </a:p>
@@ -4523,16 +4523,6 @@
         <p15:guide id="4" pos="325">
           <p15:clr>
             <a:srgbClr val="A4A3A4"/>
-          </p15:clr>
-        </p15:guide>
-        <p15:guide id="5" orient="horz" pos="459">
-          <p15:clr>
-            <a:srgbClr val="F26B43"/>
-          </p15:clr>
-        </p15:guide>
-        <p15:guide id="6" orient="horz" pos="187">
-          <p15:clr>
-            <a:srgbClr val="F26B43"/>
           </p15:clr>
         </p15:guide>
       </p15:sldGuideLst>

</xml_diff>